<commit_message>
fix: resolve pipeline diagram overlap and remove "honest" phrasing
Pipeline diagram: the sprawl callout box (y=310) overlapped the bottom
source box (Events, y=292–348). Moved callout to y=380 and increased
canvas height from 480 to 560 to eliminate the overlap.

Speaker notes: replaced "honest slide" and "honest caveat" with
neutral phrasing — the original wording implied prior content was
not straightforward.
</commit_message>
<xml_diff>
--- a/presentation/data-mesh-101/The_Data_Mesh_101.pptx
+++ b/presentation/data-mesh-101/The_Data_Mesh_101.pptx
@@ -780,7 +780,7 @@
           <a:p>
             <a:r>
               <a:rPr lang="en-US" dirty="0"/>
-              <a:t>The honest slide. Not every organization needs a mesh. The question is whether the bottleneck is technical (better tools solve it) or organizational (who owns what). Walk each:
+              <a:t>This is the fitness slide. Not every organization needs a mesh. The question is whether the bottleneck is technical (better tools solve it) or organizational (who owns what). Walk each:
 • Pipelines fit when the plumbing is simple enough that sprawl hasn't started. A handful of integrations, stable flows, known sources and destinations. Don't add complexity before the problem demands it.
 • Warehouses fit when the organization needs a single source of truth for BI and reporting, and a central team has the capacity to curate the data. If the bottleneck is 'we don't know the truth,' the warehouse is the answer.
 • Lakes fit when the data is heterogeneous — logs, events, images, ML training sets — and the scale or workload patterns exceed what a warehouse handles. The bottleneck is format rigidity, not organizational ownership.
@@ -1584,7 +1584,7 @@
               <a:rPr lang="en-US" dirty="0"/>
               <a:t>This is the pivot slide — from what came before to what the mesh proposes. The key insight: all three prior patterns centralize data and hand ownership to a single team. The technology improves generation by generation — from bespoke pipelines, to a governed warehouse, to a flexible lake — but the organizational shape stays the same. One team at the center, receiving requests from every domain, owning data it did not produce, modeling concepts it does not deeply understand, scaling linearly while demands grow combinatorially.
 The mesh changes the axis: instead of a better center, decentralize ownership. Each domain owns its data as a product. A shared platform provides streaming, storage, registries, observability — so domains don't each build their own. Federated governance keeps the products interoperable — through platform-enforced standards, not review boards.
-Critical clarification: the mesh is not a replacement for warehouses or lakes. A domain may use a warehouse internally. The reorganization is about who owns the data — not which database to pick. And the honest caveat: the mesh earns its complexity in organizations with many domains, many consumers, and the maturity to operate federated ownership. For smaller teams, a well-run warehouse may be exactly right.</a:t>
+Critical clarification: the mesh is not a replacement for warehouses or lakes. A domain may use a warehouse internally. The reorganization is about who owns the data — not which database to pick. An important caveat: the mesh earns its complexity in organizations with many domains, many consumers, and the maturity to operate federated ownership. For smaller teams, a well-run warehouse may be exactly right.</a:t>
             </a:r>
             <a:endParaRPr lang="en-US" dirty="0"/>
           </a:p>
@@ -3936,8 +3936,8 @@
         </p:blipFill>
         <p:spPr>
           <a:xfrm>
-            <a:off x="1261326" y="1645920"/>
-            <a:ext cx="9669043" cy="3931920"/>
+            <a:off x="1954192" y="1645920"/>
+            <a:ext cx="8283312" cy="3931920"/>
           </a:xfrm>
           <a:prstGeom prst="rect">
             <a:avLst/>

</xml_diff>